<commit_message>
w7: upgrade slides templates
Ultraworked with [Sisyphus](https://github.com/code-yeongyu/oh-my-openagent)

Co-authored-by: Sisyphus <clio-agent@sisyphuslabs.ai>
</commit_message>
<xml_diff>
--- a/packages/skills/slides/templates/corporate.pptx
+++ b/packages/skills/slides/templates/corporate.pptx
@@ -6,6 +6,10 @@
   </p:sldMasterIdLst>
   <p:sldIdLst>
     <p:sldId id="256" r:id="rId7"/>
+    <p:sldId id="257" r:id="rId8"/>
+    <p:sldId id="258" r:id="rId9"/>
+    <p:sldId id="259" r:id="rId10"/>
+    <p:sldId id="260" r:id="rId11"/>
   </p:sldIdLst>
   <p:sldSz cx="12191695" cy="6858000" type="screen4x3"/>
   <p:notesSz cx="6858000" cy="9144000"/>
@@ -3084,7 +3088,7 @@
     <p:bg>
       <p:bgPr>
         <a:solidFill>
-          <a:srgbClr val="F5F8FC"/>
+          <a:srgbClr val="F8FAFC"/>
         </a:solidFill>
         <a:effectLst/>
       </p:bgPr>
@@ -3104,8 +3108,8 @@
         </p:nvSpPr>
         <p:spPr>
           <a:xfrm>
-            <a:off x="731520" y="2286000"/>
-            <a:ext cx="10515600" cy="914400"/>
+            <a:off x="640080" y="777240"/>
+            <a:ext cx="5212080" cy="731520"/>
           </a:xfrm>
           <a:prstGeom prst="rect">
             <a:avLst/>
@@ -3113,19 +3117,18 @@
           <a:noFill/>
         </p:spPr>
         <p:txBody>
-          <a:bodyPr wrap="none">
+          <a:bodyPr wrap="none" lIns="0" rIns="0" anchor="t">
             <a:spAutoFit/>
           </a:bodyPr>
           <a:lstStyle/>
           <a:p>
-            <a:pPr>
-              <a:defRPr sz="4400" b="1">
+            <a:r>
+              <a:rPr sz="3400" b="1">
                 <a:solidFill>
-                  <a:srgbClr val="1F4E79"/>
+                  <a:srgbClr val="0B1F3A"/>
                 </a:solidFill>
-              </a:defRPr>
-            </a:pPr>
-            <a:r>
+                <a:latin typeface="Inter"/>
+              </a:rPr>
               <a:t>Corporate Template</a:t>
             </a:r>
           </a:p>
@@ -3139,8 +3142,8 @@
         </p:nvSpPr>
         <p:spPr>
           <a:xfrm>
-            <a:off x="777240" y="3246120"/>
-            <a:ext cx="9144000" cy="457200"/>
+            <a:off x="658368" y="1572768"/>
+            <a:ext cx="4754880" cy="411480"/>
           </a:xfrm>
           <a:prstGeom prst="rect">
             <a:avLst/>
@@ -3148,16 +3151,1348 @@
           <a:noFill/>
         </p:spPr>
         <p:txBody>
-          <a:bodyPr wrap="none">
+          <a:bodyPr wrap="none" lIns="0" rIns="0" anchor="t">
             <a:spAutoFit/>
           </a:bodyPr>
           <a:lstStyle/>
           <a:p>
-            <a:pPr>
-              <a:defRPr sz="1800"/>
-            </a:pPr>
-            <a:r>
-              <a:t>Mantle productivity starter deck</a:t>
+            <a:r>
+              <a:rPr sz="1700" b="0">
+                <a:solidFill>
+                  <a:srgbClr val="475569"/>
+                </a:solidFill>
+                <a:latin typeface="Inter"/>
+              </a:rPr>
+              <a:t>Navy and teal executive reporting deck</a:t>
+            </a:r>
+          </a:p>
+        </p:txBody>
+      </p:sp>
+      <p:sp>
+        <p:nvSpPr>
+          <p:cNvPr id="4" name="Rounded Rectangle 3"/>
+          <p:cNvSpPr/>
+          <p:nvPr/>
+        </p:nvSpPr>
+        <p:spPr>
+          <a:xfrm>
+            <a:off x="658368" y="2148840"/>
+            <a:ext cx="2057400" cy="384048"/>
+          </a:xfrm>
+          <a:prstGeom prst="roundRect">
+            <a:avLst/>
+          </a:prstGeom>
+          <a:solidFill>
+            <a:srgbClr val="E6FFFA"/>
+          </a:solidFill>
+          <a:ln>
+            <a:solidFill>
+              <a:srgbClr val="0F766E"/>
+            </a:solidFill>
+          </a:ln>
+        </p:spPr>
+        <p:style>
+          <a:lnRef idx="1">
+            <a:schemeClr val="accent1"/>
+          </a:lnRef>
+          <a:fillRef idx="3">
+            <a:schemeClr val="accent1"/>
+          </a:fillRef>
+          <a:effectRef idx="2">
+            <a:schemeClr val="accent1"/>
+          </a:effectRef>
+          <a:fontRef idx="minor">
+            <a:schemeClr val="lt1"/>
+          </a:fontRef>
+        </p:style>
+        <p:txBody>
+          <a:bodyPr rtlCol="0" anchor="ctr"/>
+          <a:lstStyle/>
+          <a:p>
+            <a:pPr algn="ctr"/>
+            <a:r>
+              <a:rPr sz="1100" b="1">
+                <a:solidFill>
+                  <a:srgbClr val="0F766E"/>
+                </a:solidFill>
+                <a:latin typeface="Inter"/>
+              </a:rPr>
+              <a:t>Presentation Template</a:t>
+            </a:r>
+          </a:p>
+        </p:txBody>
+      </p:sp>
+      <p:sp>
+        <p:nvSpPr>
+          <p:cNvPr id="5" name="Rectangle 4"/>
+          <p:cNvSpPr/>
+          <p:nvPr/>
+        </p:nvSpPr>
+        <p:spPr>
+          <a:xfrm>
+            <a:off x="6126480" y="685800"/>
+            <a:ext cx="5257800" cy="4206240"/>
+          </a:xfrm>
+          <a:prstGeom prst="rect">
+            <a:avLst/>
+          </a:prstGeom>
+          <a:solidFill>
+            <a:srgbClr val="E6FFFA"/>
+          </a:solidFill>
+          <a:ln w="19050">
+            <a:solidFill>
+              <a:srgbClr val="0F766E"/>
+            </a:solidFill>
+          </a:ln>
+        </p:spPr>
+        <p:style>
+          <a:lnRef idx="1">
+            <a:schemeClr val="accent1"/>
+          </a:lnRef>
+          <a:fillRef idx="3">
+            <a:schemeClr val="accent1"/>
+          </a:fillRef>
+          <a:effectRef idx="2">
+            <a:schemeClr val="accent1"/>
+          </a:effectRef>
+          <a:fontRef idx="minor">
+            <a:schemeClr val="lt1"/>
+          </a:fontRef>
+        </p:style>
+        <p:txBody>
+          <a:bodyPr rtlCol="0" anchor="ctr"/>
+          <a:lstStyle/>
+          <a:p>
+            <a:pPr algn="ctr"/>
+            <a:r>
+              <a:rPr sz="1400">
+                <a:solidFill>
+                  <a:srgbClr val="475569"/>
+                </a:solidFill>
+                <a:latin typeface="Inter"/>
+              </a:rPr>
+              <a:t>Hero image placeholder</a:t>
+            </a:r>
+          </a:p>
+        </p:txBody>
+      </p:sp>
+      <p:sp>
+        <p:nvSpPr>
+          <p:cNvPr id="6" name="Rectangle 5"/>
+          <p:cNvSpPr/>
+          <p:nvPr/>
+        </p:nvSpPr>
+        <p:spPr>
+          <a:xfrm>
+            <a:off x="594360" y="6446520"/>
+            <a:ext cx="10104120" cy="27432"/>
+          </a:xfrm>
+          <a:prstGeom prst="rect">
+            <a:avLst/>
+          </a:prstGeom>
+          <a:solidFill>
+            <a:srgbClr val="0F766E"/>
+          </a:solidFill>
+          <a:ln>
+            <a:noFill/>
+          </a:ln>
+        </p:spPr>
+        <p:style>
+          <a:lnRef idx="1">
+            <a:schemeClr val="accent1"/>
+          </a:lnRef>
+          <a:fillRef idx="3">
+            <a:schemeClr val="accent1"/>
+          </a:fillRef>
+          <a:effectRef idx="2">
+            <a:schemeClr val="accent1"/>
+          </a:effectRef>
+          <a:fontRef idx="minor">
+            <a:schemeClr val="lt1"/>
+          </a:fontRef>
+        </p:style>
+        <p:txBody>
+          <a:bodyPr rtlCol="0" anchor="ctr"/>
+          <a:lstStyle/>
+          <a:p>
+            <a:pPr algn="ctr"/>
+          </a:p>
+        </p:txBody>
+      </p:sp>
+      <p:sp>
+        <p:nvSpPr>
+          <p:cNvPr id="7" name="TextBox 6"/>
+          <p:cNvSpPr txBox="1"/>
+          <p:nvPr/>
+        </p:nvSpPr>
+        <p:spPr>
+          <a:xfrm>
+            <a:off x="594360" y="6510528"/>
+            <a:ext cx="4572000" cy="228600"/>
+          </a:xfrm>
+          <a:prstGeom prst="rect">
+            <a:avLst/>
+          </a:prstGeom>
+          <a:noFill/>
+        </p:spPr>
+        <p:txBody>
+          <a:bodyPr wrap="none" lIns="0" rIns="0" anchor="t">
+            <a:spAutoFit/>
+          </a:bodyPr>
+          <a:lstStyle/>
+          <a:p>
+            <a:r>
+              <a:rPr sz="800" b="0">
+                <a:solidFill>
+                  <a:srgbClr val="475569"/>
+                </a:solidFill>
+                <a:latin typeface="Inter"/>
+              </a:rPr>
+              <a:t>Title slide · image + subtitle layout</a:t>
+            </a:r>
+          </a:p>
+        </p:txBody>
+      </p:sp>
+    </p:spTree>
+  </p:cSld>
+  <p:clrMapOvr>
+    <a:masterClrMapping/>
+  </p:clrMapOvr>
+</p:sld>
+</file>
+
+<file path=ppt/slides/slide2.xml><?xml version="1.0" encoding="utf-8"?>
+<p:sld xmlns:a="http://schemas.openxmlformats.org/drawingml/2006/main" xmlns:p="http://schemas.openxmlformats.org/presentationml/2006/main" xmlns:r="http://schemas.openxmlformats.org/officeDocument/2006/relationships">
+  <p:cSld>
+    <p:bg>
+      <p:bgPr>
+        <a:solidFill>
+          <a:srgbClr val="0F766E"/>
+        </a:solidFill>
+        <a:effectLst/>
+      </p:bgPr>
+    </p:bg>
+    <p:spTree>
+      <p:nvGrpSpPr>
+        <p:cNvPr id="1" name=""/>
+        <p:cNvGrpSpPr/>
+        <p:nvPr/>
+      </p:nvGrpSpPr>
+      <p:grpSpPr/>
+      <p:sp>
+        <p:nvSpPr>
+          <p:cNvPr id="2" name="TextBox 1"/>
+          <p:cNvSpPr txBox="1"/>
+          <p:nvPr/>
+        </p:nvSpPr>
+        <p:spPr>
+          <a:xfrm>
+            <a:off x="777240" y="777240"/>
+            <a:ext cx="1280160" cy="457200"/>
+          </a:xfrm>
+          <a:prstGeom prst="rect">
+            <a:avLst/>
+          </a:prstGeom>
+          <a:noFill/>
+        </p:spPr>
+        <p:txBody>
+          <a:bodyPr wrap="none" lIns="0" rIns="0" anchor="t">
+            <a:spAutoFit/>
+          </a:bodyPr>
+          <a:lstStyle/>
+          <a:p>
+            <a:r>
+              <a:rPr sz="1600" b="1">
+                <a:solidFill>
+                  <a:srgbClr val="FFFFFF"/>
+                </a:solidFill>
+                <a:latin typeface="Inter"/>
+              </a:rPr>
+              <a:t>01</a:t>
+            </a:r>
+          </a:p>
+        </p:txBody>
+      </p:sp>
+      <p:sp>
+        <p:nvSpPr>
+          <p:cNvPr id="3" name="TextBox 2"/>
+          <p:cNvSpPr txBox="1"/>
+          <p:nvPr/>
+        </p:nvSpPr>
+        <p:spPr>
+          <a:xfrm>
+            <a:off x="777240" y="2331720"/>
+            <a:ext cx="7680960" cy="822960"/>
+          </a:xfrm>
+          <a:prstGeom prst="rect">
+            <a:avLst/>
+          </a:prstGeom>
+          <a:noFill/>
+        </p:spPr>
+        <p:txBody>
+          <a:bodyPr wrap="none" lIns="0" rIns="0" anchor="t">
+            <a:spAutoFit/>
+          </a:bodyPr>
+          <a:lstStyle/>
+          <a:p>
+            <a:r>
+              <a:rPr sz="3800" b="1">
+                <a:solidFill>
+                  <a:srgbClr val="FFFFFF"/>
+                </a:solidFill>
+                <a:latin typeface="Inter"/>
+              </a:rPr>
+              <a:t>Section Divider</a:t>
+            </a:r>
+          </a:p>
+        </p:txBody>
+      </p:sp>
+      <p:sp>
+        <p:nvSpPr>
+          <p:cNvPr id="4" name="TextBox 3"/>
+          <p:cNvSpPr txBox="1"/>
+          <p:nvPr/>
+        </p:nvSpPr>
+        <p:spPr>
+          <a:xfrm>
+            <a:off x="822960" y="3218688"/>
+            <a:ext cx="6766560" cy="502920"/>
+          </a:xfrm>
+          <a:prstGeom prst="rect">
+            <a:avLst/>
+          </a:prstGeom>
+          <a:noFill/>
+        </p:spPr>
+        <p:txBody>
+          <a:bodyPr wrap="none" lIns="0" rIns="0" anchor="t">
+            <a:spAutoFit/>
+          </a:bodyPr>
+          <a:lstStyle/>
+          <a:p>
+            <a:r>
+              <a:rPr sz="1800" b="0">
+                <a:solidFill>
+                  <a:srgbClr val="FFFFFF"/>
+                </a:solidFill>
+                <a:latin typeface="Inter"/>
+              </a:rPr>
+              <a:t>Use this slide to reset context and introduce the next narrative arc.</a:t>
+            </a:r>
+          </a:p>
+        </p:txBody>
+      </p:sp>
+      <p:sp>
+        <p:nvSpPr>
+          <p:cNvPr id="5" name="Rectangle 4"/>
+          <p:cNvSpPr/>
+          <p:nvPr/>
+        </p:nvSpPr>
+        <p:spPr>
+          <a:xfrm>
+            <a:off x="9509760" y="0"/>
+            <a:ext cx="2697480" cy="6858000"/>
+          </a:xfrm>
+          <a:prstGeom prst="rect">
+            <a:avLst/>
+          </a:prstGeom>
+          <a:solidFill>
+            <a:srgbClr val="164E63"/>
+          </a:solidFill>
+          <a:ln>
+            <a:noFill/>
+          </a:ln>
+        </p:spPr>
+        <p:style>
+          <a:lnRef idx="1">
+            <a:schemeClr val="accent1"/>
+          </a:lnRef>
+          <a:fillRef idx="3">
+            <a:schemeClr val="accent1"/>
+          </a:fillRef>
+          <a:effectRef idx="2">
+            <a:schemeClr val="accent1"/>
+          </a:effectRef>
+          <a:fontRef idx="minor">
+            <a:schemeClr val="lt1"/>
+          </a:fontRef>
+        </p:style>
+        <p:txBody>
+          <a:bodyPr rtlCol="0" anchor="ctr"/>
+          <a:lstStyle/>
+          <a:p>
+            <a:pPr algn="ctr"/>
+          </a:p>
+        </p:txBody>
+      </p:sp>
+    </p:spTree>
+  </p:cSld>
+  <p:clrMapOvr>
+    <a:masterClrMapping/>
+  </p:clrMapOvr>
+</p:sld>
+</file>
+
+<file path=ppt/slides/slide3.xml><?xml version="1.0" encoding="utf-8"?>
+<p:sld xmlns:a="http://schemas.openxmlformats.org/drawingml/2006/main" xmlns:p="http://schemas.openxmlformats.org/presentationml/2006/main" xmlns:r="http://schemas.openxmlformats.org/officeDocument/2006/relationships">
+  <p:cSld>
+    <p:bg>
+      <p:bgPr>
+        <a:solidFill>
+          <a:srgbClr val="F8FAFC"/>
+        </a:solidFill>
+        <a:effectLst/>
+      </p:bgPr>
+    </p:bg>
+    <p:spTree>
+      <p:nvGrpSpPr>
+        <p:cNvPr id="1" name=""/>
+        <p:cNvGrpSpPr/>
+        <p:nvPr/>
+      </p:nvGrpSpPr>
+      <p:grpSpPr/>
+      <p:sp>
+        <p:nvSpPr>
+          <p:cNvPr id="2" name="TextBox 1"/>
+          <p:cNvSpPr txBox="1"/>
+          <p:nvPr/>
+        </p:nvSpPr>
+        <p:spPr>
+          <a:xfrm>
+            <a:off x="594360" y="502920"/>
+            <a:ext cx="7315200" cy="502920"/>
+          </a:xfrm>
+          <a:prstGeom prst="rect">
+            <a:avLst/>
+          </a:prstGeom>
+          <a:noFill/>
+        </p:spPr>
+        <p:txBody>
+          <a:bodyPr wrap="none" lIns="0" rIns="0" anchor="t">
+            <a:spAutoFit/>
+          </a:bodyPr>
+          <a:lstStyle/>
+          <a:p>
+            <a:r>
+              <a:rPr sz="2600" b="1">
+                <a:solidFill>
+                  <a:srgbClr val="0B1F3A"/>
+                </a:solidFill>
+                <a:latin typeface="Inter"/>
+              </a:rPr>
+              <a:t>Two-Column Content</a:t>
+            </a:r>
+          </a:p>
+        </p:txBody>
+      </p:sp>
+      <p:sp>
+        <p:nvSpPr>
+          <p:cNvPr id="3" name="TextBox 2"/>
+          <p:cNvSpPr txBox="1"/>
+          <p:nvPr/>
+        </p:nvSpPr>
+        <p:spPr>
+          <a:xfrm>
+            <a:off x="731520" y="1325880"/>
+            <a:ext cx="4389120" cy="365760"/>
+          </a:xfrm>
+          <a:prstGeom prst="rect">
+            <a:avLst/>
+          </a:prstGeom>
+          <a:noFill/>
+        </p:spPr>
+        <p:txBody>
+          <a:bodyPr wrap="none" lIns="0" rIns="0" anchor="t">
+            <a:spAutoFit/>
+          </a:bodyPr>
+          <a:lstStyle/>
+          <a:p>
+            <a:r>
+              <a:rPr sz="1600" b="1">
+                <a:solidFill>
+                  <a:srgbClr val="0F766E"/>
+                </a:solidFill>
+                <a:latin typeface="Inter"/>
+              </a:rPr>
+              <a:t>Left narrative</a:t>
+            </a:r>
+          </a:p>
+        </p:txBody>
+      </p:sp>
+      <p:sp>
+        <p:nvSpPr>
+          <p:cNvPr id="4" name="TextBox 3"/>
+          <p:cNvSpPr txBox="1"/>
+          <p:nvPr/>
+        </p:nvSpPr>
+        <p:spPr>
+          <a:xfrm>
+            <a:off x="731520" y="1783080"/>
+            <a:ext cx="4480560" cy="2286000"/>
+          </a:xfrm>
+          <a:prstGeom prst="rect">
+            <a:avLst/>
+          </a:prstGeom>
+          <a:noFill/>
+        </p:spPr>
+        <p:txBody>
+          <a:bodyPr wrap="none" lIns="0" rIns="0" anchor="t">
+            <a:spAutoFit/>
+          </a:bodyPr>
+          <a:lstStyle/>
+          <a:p>
+            <a:r>
+              <a:rPr sz="1500" b="0">
+                <a:solidFill>
+                  <a:srgbClr val="0B1F3A"/>
+                </a:solidFill>
+                <a:latin typeface="Inter"/>
+              </a:rPr>
+              <a:t>• Key insight with supporting detail</a:t>
+            </a:r>
+            <a:br/>
+            <a:r>
+              <a:t>• Evidence point or customer quote</a:t>
+            </a:r>
+            <a:br/>
+            <a:r>
+              <a:t>• Decision implication</a:t>
+            </a:r>
+          </a:p>
+        </p:txBody>
+      </p:sp>
+      <p:sp>
+        <p:nvSpPr>
+          <p:cNvPr id="5" name="TextBox 4"/>
+          <p:cNvSpPr txBox="1"/>
+          <p:nvPr/>
+        </p:nvSpPr>
+        <p:spPr>
+          <a:xfrm>
+            <a:off x="6217920" y="1325880"/>
+            <a:ext cx="4389120" cy="365760"/>
+          </a:xfrm>
+          <a:prstGeom prst="rect">
+            <a:avLst/>
+          </a:prstGeom>
+          <a:noFill/>
+        </p:spPr>
+        <p:txBody>
+          <a:bodyPr wrap="none" lIns="0" rIns="0" anchor="t">
+            <a:spAutoFit/>
+          </a:bodyPr>
+          <a:lstStyle/>
+          <a:p>
+            <a:r>
+              <a:rPr sz="1600" b="1">
+                <a:solidFill>
+                  <a:srgbClr val="0F766E"/>
+                </a:solidFill>
+                <a:latin typeface="Inter"/>
+              </a:rPr>
+              <a:t>Right narrative</a:t>
+            </a:r>
+          </a:p>
+        </p:txBody>
+      </p:sp>
+      <p:sp>
+        <p:nvSpPr>
+          <p:cNvPr id="6" name="TextBox 5"/>
+          <p:cNvSpPr txBox="1"/>
+          <p:nvPr/>
+        </p:nvSpPr>
+        <p:spPr>
+          <a:xfrm>
+            <a:off x="6217920" y="1783080"/>
+            <a:ext cx="4480560" cy="2286000"/>
+          </a:xfrm>
+          <a:prstGeom prst="rect">
+            <a:avLst/>
+          </a:prstGeom>
+          <a:noFill/>
+        </p:spPr>
+        <p:txBody>
+          <a:bodyPr wrap="none" lIns="0" rIns="0" anchor="t">
+            <a:spAutoFit/>
+          </a:bodyPr>
+          <a:lstStyle/>
+          <a:p>
+            <a:r>
+              <a:rPr sz="1500" b="0">
+                <a:solidFill>
+                  <a:srgbClr val="0B1F3A"/>
+                </a:solidFill>
+                <a:latin typeface="Inter"/>
+              </a:rPr>
+              <a:t>• Counterpoint or operational risk</a:t>
+            </a:r>
+            <a:br/>
+            <a:r>
+              <a:t>• Quantified metric or benchmark</a:t>
+            </a:r>
+            <a:br/>
+            <a:r>
+              <a:t>• Recommended next action</a:t>
+            </a:r>
+          </a:p>
+        </p:txBody>
+      </p:sp>
+      <p:sp>
+        <p:nvSpPr>
+          <p:cNvPr id="7" name="Rectangle 6"/>
+          <p:cNvSpPr/>
+          <p:nvPr/>
+        </p:nvSpPr>
+        <p:spPr>
+          <a:xfrm>
+            <a:off x="594360" y="6446520"/>
+            <a:ext cx="10104120" cy="27432"/>
+          </a:xfrm>
+          <a:prstGeom prst="rect">
+            <a:avLst/>
+          </a:prstGeom>
+          <a:solidFill>
+            <a:srgbClr val="0F766E"/>
+          </a:solidFill>
+          <a:ln>
+            <a:noFill/>
+          </a:ln>
+        </p:spPr>
+        <p:style>
+          <a:lnRef idx="1">
+            <a:schemeClr val="accent1"/>
+          </a:lnRef>
+          <a:fillRef idx="3">
+            <a:schemeClr val="accent1"/>
+          </a:fillRef>
+          <a:effectRef idx="2">
+            <a:schemeClr val="accent1"/>
+          </a:effectRef>
+          <a:fontRef idx="minor">
+            <a:schemeClr val="lt1"/>
+          </a:fontRef>
+        </p:style>
+        <p:txBody>
+          <a:bodyPr rtlCol="0" anchor="ctr"/>
+          <a:lstStyle/>
+          <a:p>
+            <a:pPr algn="ctr"/>
+          </a:p>
+        </p:txBody>
+      </p:sp>
+      <p:sp>
+        <p:nvSpPr>
+          <p:cNvPr id="8" name="TextBox 7"/>
+          <p:cNvSpPr txBox="1"/>
+          <p:nvPr/>
+        </p:nvSpPr>
+        <p:spPr>
+          <a:xfrm>
+            <a:off x="594360" y="6510528"/>
+            <a:ext cx="4572000" cy="228600"/>
+          </a:xfrm>
+          <a:prstGeom prst="rect">
+            <a:avLst/>
+          </a:prstGeom>
+          <a:noFill/>
+        </p:spPr>
+        <p:txBody>
+          <a:bodyPr wrap="none" lIns="0" rIns="0" anchor="t">
+            <a:spAutoFit/>
+          </a:bodyPr>
+          <a:lstStyle/>
+          <a:p>
+            <a:r>
+              <a:rPr sz="800" b="0">
+                <a:solidFill>
+                  <a:srgbClr val="475569"/>
+                </a:solidFill>
+                <a:latin typeface="Inter"/>
+              </a:rPr>
+              <a:t>Two-column content layout</a:t>
+            </a:r>
+          </a:p>
+        </p:txBody>
+      </p:sp>
+    </p:spTree>
+  </p:cSld>
+  <p:clrMapOvr>
+    <a:masterClrMapping/>
+  </p:clrMapOvr>
+</p:sld>
+</file>
+
+<file path=ppt/slides/slide4.xml><?xml version="1.0" encoding="utf-8"?>
+<p:sld xmlns:a="http://schemas.openxmlformats.org/drawingml/2006/main" xmlns:p="http://schemas.openxmlformats.org/presentationml/2006/main" xmlns:r="http://schemas.openxmlformats.org/officeDocument/2006/relationships">
+  <p:cSld>
+    <p:bg>
+      <p:bgPr>
+        <a:solidFill>
+          <a:srgbClr val="F8FAFC"/>
+        </a:solidFill>
+        <a:effectLst/>
+      </p:bgPr>
+    </p:bg>
+    <p:spTree>
+      <p:nvGrpSpPr>
+        <p:cNvPr id="1" name=""/>
+        <p:cNvGrpSpPr/>
+        <p:nvPr/>
+      </p:nvGrpSpPr>
+      <p:grpSpPr/>
+      <p:sp>
+        <p:nvSpPr>
+          <p:cNvPr id="2" name="TextBox 1"/>
+          <p:cNvSpPr txBox="1"/>
+          <p:nvPr/>
+        </p:nvSpPr>
+        <p:spPr>
+          <a:xfrm>
+            <a:off x="594360" y="502920"/>
+            <a:ext cx="7315200" cy="502920"/>
+          </a:xfrm>
+          <a:prstGeom prst="rect">
+            <a:avLst/>
+          </a:prstGeom>
+          <a:noFill/>
+        </p:spPr>
+        <p:txBody>
+          <a:bodyPr wrap="none" lIns="0" rIns="0" anchor="t">
+            <a:spAutoFit/>
+          </a:bodyPr>
+          <a:lstStyle/>
+          <a:p>
+            <a:r>
+              <a:rPr sz="2600" b="1">
+                <a:solidFill>
+                  <a:srgbClr val="0B1F3A"/>
+                </a:solidFill>
+                <a:latin typeface="Inter"/>
+              </a:rPr>
+              <a:t>Chart Placeholder</a:t>
+            </a:r>
+          </a:p>
+        </p:txBody>
+      </p:sp>
+      <p:sp>
+        <p:nvSpPr>
+          <p:cNvPr id="3" name="Rectangle 2"/>
+          <p:cNvSpPr/>
+          <p:nvPr/>
+        </p:nvSpPr>
+        <p:spPr>
+          <a:xfrm>
+            <a:off x="777240" y="1234440"/>
+            <a:ext cx="6675120" cy="4389120"/>
+          </a:xfrm>
+          <a:prstGeom prst="rect">
+            <a:avLst/>
+          </a:prstGeom>
+          <a:solidFill>
+            <a:srgbClr val="FFFFFF"/>
+          </a:solidFill>
+          <a:ln>
+            <a:solidFill>
+              <a:srgbClr val="0F766E"/>
+            </a:solidFill>
+          </a:ln>
+        </p:spPr>
+        <p:style>
+          <a:lnRef idx="1">
+            <a:schemeClr val="accent1"/>
+          </a:lnRef>
+          <a:fillRef idx="3">
+            <a:schemeClr val="accent1"/>
+          </a:fillRef>
+          <a:effectRef idx="2">
+            <a:schemeClr val="accent1"/>
+          </a:effectRef>
+          <a:fontRef idx="minor">
+            <a:schemeClr val="lt1"/>
+          </a:fontRef>
+        </p:style>
+        <p:txBody>
+          <a:bodyPr rtlCol="0" anchor="ctr"/>
+          <a:lstStyle/>
+          <a:p>
+            <a:pPr algn="ctr"/>
+            <a:r>
+              <a:t>Chart / graph placeholder</a:t>
+            </a:r>
+          </a:p>
+        </p:txBody>
+      </p:sp>
+      <p:sp>
+        <p:nvSpPr>
+          <p:cNvPr id="4" name="Rectangle 3"/>
+          <p:cNvSpPr/>
+          <p:nvPr/>
+        </p:nvSpPr>
+        <p:spPr>
+          <a:xfrm>
+            <a:off x="2148840" y="4251960"/>
+            <a:ext cx="438912" cy="1005840"/>
+          </a:xfrm>
+          <a:prstGeom prst="rect">
+            <a:avLst/>
+          </a:prstGeom>
+          <a:solidFill>
+            <a:srgbClr val="0F766E"/>
+          </a:solidFill>
+          <a:ln>
+            <a:noFill/>
+          </a:ln>
+        </p:spPr>
+        <p:style>
+          <a:lnRef idx="1">
+            <a:schemeClr val="accent1"/>
+          </a:lnRef>
+          <a:fillRef idx="3">
+            <a:schemeClr val="accent1"/>
+          </a:fillRef>
+          <a:effectRef idx="2">
+            <a:schemeClr val="accent1"/>
+          </a:effectRef>
+          <a:fontRef idx="minor">
+            <a:schemeClr val="lt1"/>
+          </a:fontRef>
+        </p:style>
+        <p:txBody>
+          <a:bodyPr rtlCol="0" anchor="ctr"/>
+          <a:lstStyle/>
+          <a:p>
+            <a:pPr algn="ctr"/>
+          </a:p>
+        </p:txBody>
+      </p:sp>
+      <p:sp>
+        <p:nvSpPr>
+          <p:cNvPr id="5" name="Rectangle 4"/>
+          <p:cNvSpPr/>
+          <p:nvPr/>
+        </p:nvSpPr>
+        <p:spPr>
+          <a:xfrm>
+            <a:off x="3063240" y="3520440"/>
+            <a:ext cx="438912" cy="1737360"/>
+          </a:xfrm>
+          <a:prstGeom prst="rect">
+            <a:avLst/>
+          </a:prstGeom>
+          <a:solidFill>
+            <a:srgbClr val="164E63"/>
+          </a:solidFill>
+          <a:ln>
+            <a:noFill/>
+          </a:ln>
+        </p:spPr>
+        <p:style>
+          <a:lnRef idx="1">
+            <a:schemeClr val="accent1"/>
+          </a:lnRef>
+          <a:fillRef idx="3">
+            <a:schemeClr val="accent1"/>
+          </a:fillRef>
+          <a:effectRef idx="2">
+            <a:schemeClr val="accent1"/>
+          </a:effectRef>
+          <a:fontRef idx="minor">
+            <a:schemeClr val="lt1"/>
+          </a:fontRef>
+        </p:style>
+        <p:txBody>
+          <a:bodyPr rtlCol="0" anchor="ctr"/>
+          <a:lstStyle/>
+          <a:p>
+            <a:pPr algn="ctr"/>
+          </a:p>
+        </p:txBody>
+      </p:sp>
+      <p:sp>
+        <p:nvSpPr>
+          <p:cNvPr id="6" name="Rectangle 5"/>
+          <p:cNvSpPr/>
+          <p:nvPr/>
+        </p:nvSpPr>
+        <p:spPr>
+          <a:xfrm>
+            <a:off x="3977639" y="2788920"/>
+            <a:ext cx="438912" cy="2468880"/>
+          </a:xfrm>
+          <a:prstGeom prst="rect">
+            <a:avLst/>
+          </a:prstGeom>
+          <a:solidFill>
+            <a:srgbClr val="0F766E"/>
+          </a:solidFill>
+          <a:ln>
+            <a:noFill/>
+          </a:ln>
+        </p:spPr>
+        <p:style>
+          <a:lnRef idx="1">
+            <a:schemeClr val="accent1"/>
+          </a:lnRef>
+          <a:fillRef idx="3">
+            <a:schemeClr val="accent1"/>
+          </a:fillRef>
+          <a:effectRef idx="2">
+            <a:schemeClr val="accent1"/>
+          </a:effectRef>
+          <a:fontRef idx="minor">
+            <a:schemeClr val="lt1"/>
+          </a:fontRef>
+        </p:style>
+        <p:txBody>
+          <a:bodyPr rtlCol="0" anchor="ctr"/>
+          <a:lstStyle/>
+          <a:p>
+            <a:pPr algn="ctr"/>
+          </a:p>
+        </p:txBody>
+      </p:sp>
+      <p:sp>
+        <p:nvSpPr>
+          <p:cNvPr id="7" name="Rectangle 6"/>
+          <p:cNvSpPr/>
+          <p:nvPr/>
+        </p:nvSpPr>
+        <p:spPr>
+          <a:xfrm>
+            <a:off x="4892040" y="2148840"/>
+            <a:ext cx="438912" cy="3108960"/>
+          </a:xfrm>
+          <a:prstGeom prst="rect">
+            <a:avLst/>
+          </a:prstGeom>
+          <a:solidFill>
+            <a:srgbClr val="164E63"/>
+          </a:solidFill>
+          <a:ln>
+            <a:noFill/>
+          </a:ln>
+        </p:spPr>
+        <p:style>
+          <a:lnRef idx="1">
+            <a:schemeClr val="accent1"/>
+          </a:lnRef>
+          <a:fillRef idx="3">
+            <a:schemeClr val="accent1"/>
+          </a:fillRef>
+          <a:effectRef idx="2">
+            <a:schemeClr val="accent1"/>
+          </a:effectRef>
+          <a:fontRef idx="minor">
+            <a:schemeClr val="lt1"/>
+          </a:fontRef>
+        </p:style>
+        <p:txBody>
+          <a:bodyPr rtlCol="0" anchor="ctr"/>
+          <a:lstStyle/>
+          <a:p>
+            <a:pPr algn="ctr"/>
+          </a:p>
+        </p:txBody>
+      </p:sp>
+      <p:sp>
+        <p:nvSpPr>
+          <p:cNvPr id="8" name="TextBox 7"/>
+          <p:cNvSpPr txBox="1"/>
+          <p:nvPr/>
+        </p:nvSpPr>
+        <p:spPr>
+          <a:xfrm>
+            <a:off x="8001000" y="1325880"/>
+            <a:ext cx="3200400" cy="320040"/>
+          </a:xfrm>
+          <a:prstGeom prst="rect">
+            <a:avLst/>
+          </a:prstGeom>
+          <a:noFill/>
+        </p:spPr>
+        <p:txBody>
+          <a:bodyPr wrap="none" lIns="0" rIns="0" anchor="t">
+            <a:spAutoFit/>
+          </a:bodyPr>
+          <a:lstStyle/>
+          <a:p>
+            <a:r>
+              <a:rPr sz="1600" b="1">
+                <a:solidFill>
+                  <a:srgbClr val="0F766E"/>
+                </a:solidFill>
+                <a:latin typeface="Inter"/>
+              </a:rPr>
+              <a:t>Key takeaway</a:t>
+            </a:r>
+          </a:p>
+        </p:txBody>
+      </p:sp>
+      <p:sp>
+        <p:nvSpPr>
+          <p:cNvPr id="9" name="TextBox 8"/>
+          <p:cNvSpPr txBox="1"/>
+          <p:nvPr/>
+        </p:nvSpPr>
+        <p:spPr>
+          <a:xfrm>
+            <a:off x="8001000" y="1783080"/>
+            <a:ext cx="3108960" cy="1280160"/>
+          </a:xfrm>
+          <a:prstGeom prst="rect">
+            <a:avLst/>
+          </a:prstGeom>
+          <a:noFill/>
+        </p:spPr>
+        <p:txBody>
+          <a:bodyPr wrap="none" lIns="0" rIns="0" anchor="t">
+            <a:spAutoFit/>
+          </a:bodyPr>
+          <a:lstStyle/>
+          <a:p>
+            <a:r>
+              <a:rPr sz="1500" b="0">
+                <a:solidFill>
+                  <a:srgbClr val="0B1F3A"/>
+                </a:solidFill>
+                <a:latin typeface="Inter"/>
+              </a:rPr>
+              <a:t>Summarize the signal in one sentence, then list the implications for the audience.</a:t>
+            </a:r>
+          </a:p>
+        </p:txBody>
+      </p:sp>
+      <p:sp>
+        <p:nvSpPr>
+          <p:cNvPr id="10" name="Rectangle 9"/>
+          <p:cNvSpPr/>
+          <p:nvPr/>
+        </p:nvSpPr>
+        <p:spPr>
+          <a:xfrm>
+            <a:off x="594360" y="6446520"/>
+            <a:ext cx="10104120" cy="27432"/>
+          </a:xfrm>
+          <a:prstGeom prst="rect">
+            <a:avLst/>
+          </a:prstGeom>
+          <a:solidFill>
+            <a:srgbClr val="0F766E"/>
+          </a:solidFill>
+          <a:ln>
+            <a:noFill/>
+          </a:ln>
+        </p:spPr>
+        <p:style>
+          <a:lnRef idx="1">
+            <a:schemeClr val="accent1"/>
+          </a:lnRef>
+          <a:fillRef idx="3">
+            <a:schemeClr val="accent1"/>
+          </a:fillRef>
+          <a:effectRef idx="2">
+            <a:schemeClr val="accent1"/>
+          </a:effectRef>
+          <a:fontRef idx="minor">
+            <a:schemeClr val="lt1"/>
+          </a:fontRef>
+        </p:style>
+        <p:txBody>
+          <a:bodyPr rtlCol="0" anchor="ctr"/>
+          <a:lstStyle/>
+          <a:p>
+            <a:pPr algn="ctr"/>
+          </a:p>
+        </p:txBody>
+      </p:sp>
+      <p:sp>
+        <p:nvSpPr>
+          <p:cNvPr id="11" name="TextBox 10"/>
+          <p:cNvSpPr txBox="1"/>
+          <p:nvPr/>
+        </p:nvSpPr>
+        <p:spPr>
+          <a:xfrm>
+            <a:off x="594360" y="6510528"/>
+            <a:ext cx="4572000" cy="228600"/>
+          </a:xfrm>
+          <a:prstGeom prst="rect">
+            <a:avLst/>
+          </a:prstGeom>
+          <a:noFill/>
+        </p:spPr>
+        <p:txBody>
+          <a:bodyPr wrap="none" lIns="0" rIns="0" anchor="t">
+            <a:spAutoFit/>
+          </a:bodyPr>
+          <a:lstStyle/>
+          <a:p>
+            <a:r>
+              <a:rPr sz="800" b="0">
+                <a:solidFill>
+                  <a:srgbClr val="475569"/>
+                </a:solidFill>
+                <a:latin typeface="Inter"/>
+              </a:rPr>
+              <a:t>Chart placeholder slide</a:t>
+            </a:r>
+          </a:p>
+        </p:txBody>
+      </p:sp>
+    </p:spTree>
+  </p:cSld>
+  <p:clrMapOvr>
+    <a:masterClrMapping/>
+  </p:clrMapOvr>
+</p:sld>
+</file>
+
+<file path=ppt/slides/slide5.xml><?xml version="1.0" encoding="utf-8"?>
+<p:sld xmlns:a="http://schemas.openxmlformats.org/drawingml/2006/main" xmlns:p="http://schemas.openxmlformats.org/presentationml/2006/main" xmlns:r="http://schemas.openxmlformats.org/officeDocument/2006/relationships">
+  <p:cSld>
+    <p:bg>
+      <p:bgPr>
+        <a:solidFill>
+          <a:srgbClr val="F8FAFC"/>
+        </a:solidFill>
+        <a:effectLst/>
+      </p:bgPr>
+    </p:bg>
+    <p:spTree>
+      <p:nvGrpSpPr>
+        <p:cNvPr id="1" name=""/>
+        <p:cNvGrpSpPr/>
+        <p:nvPr/>
+      </p:nvGrpSpPr>
+      <p:grpSpPr/>
+      <p:sp>
+        <p:nvSpPr>
+          <p:cNvPr id="2" name="TextBox 1"/>
+          <p:cNvSpPr txBox="1"/>
+          <p:nvPr/>
+        </p:nvSpPr>
+        <p:spPr>
+          <a:xfrm>
+            <a:off x="777240" y="1051560"/>
+            <a:ext cx="5303520" cy="685800"/>
+          </a:xfrm>
+          <a:prstGeom prst="rect">
+            <a:avLst/>
+          </a:prstGeom>
+          <a:noFill/>
+        </p:spPr>
+        <p:txBody>
+          <a:bodyPr wrap="none" lIns="0" rIns="0" anchor="t">
+            <a:spAutoFit/>
+          </a:bodyPr>
+          <a:lstStyle/>
+          <a:p>
+            <a:r>
+              <a:rPr sz="3800" b="1">
+                <a:solidFill>
+                  <a:srgbClr val="0B1F3A"/>
+                </a:solidFill>
+                <a:latin typeface="Inter"/>
+              </a:rPr>
+              <a:t>Thank you</a:t>
+            </a:r>
+          </a:p>
+        </p:txBody>
+      </p:sp>
+      <p:sp>
+        <p:nvSpPr>
+          <p:cNvPr id="3" name="TextBox 2"/>
+          <p:cNvSpPr txBox="1"/>
+          <p:nvPr/>
+        </p:nvSpPr>
+        <p:spPr>
+          <a:xfrm>
+            <a:off x="822960" y="1847088"/>
+            <a:ext cx="5120640" cy="411480"/>
+          </a:xfrm>
+          <a:prstGeom prst="rect">
+            <a:avLst/>
+          </a:prstGeom>
+          <a:noFill/>
+        </p:spPr>
+        <p:txBody>
+          <a:bodyPr wrap="none" lIns="0" rIns="0" anchor="t">
+            <a:spAutoFit/>
+          </a:bodyPr>
+          <a:lstStyle/>
+          <a:p>
+            <a:r>
+              <a:rPr sz="1800" b="0">
+                <a:solidFill>
+                  <a:srgbClr val="475569"/>
+                </a:solidFill>
+                <a:latin typeface="Inter"/>
+              </a:rPr>
+              <a:t>Questions, discussion, and next steps</a:t>
+            </a:r>
+          </a:p>
+        </p:txBody>
+      </p:sp>
+      <p:sp>
+        <p:nvSpPr>
+          <p:cNvPr id="4" name="Rectangle 3"/>
+          <p:cNvSpPr/>
+          <p:nvPr/>
+        </p:nvSpPr>
+        <p:spPr>
+          <a:xfrm>
+            <a:off x="6766560" y="914400"/>
+            <a:ext cx="4297680" cy="3291840"/>
+          </a:xfrm>
+          <a:prstGeom prst="rect">
+            <a:avLst/>
+          </a:prstGeom>
+          <a:solidFill>
+            <a:srgbClr val="E6FFFA"/>
+          </a:solidFill>
+          <a:ln w="19050">
+            <a:solidFill>
+              <a:srgbClr val="0F766E"/>
+            </a:solidFill>
+          </a:ln>
+        </p:spPr>
+        <p:style>
+          <a:lnRef idx="1">
+            <a:schemeClr val="accent1"/>
+          </a:lnRef>
+          <a:fillRef idx="3">
+            <a:schemeClr val="accent1"/>
+          </a:fillRef>
+          <a:effectRef idx="2">
+            <a:schemeClr val="accent1"/>
+          </a:effectRef>
+          <a:fontRef idx="minor">
+            <a:schemeClr val="lt1"/>
+          </a:fontRef>
+        </p:style>
+        <p:txBody>
+          <a:bodyPr rtlCol="0" anchor="ctr"/>
+          <a:lstStyle/>
+          <a:p>
+            <a:pPr algn="ctr"/>
+            <a:r>
+              <a:rPr sz="1400">
+                <a:solidFill>
+                  <a:srgbClr val="475569"/>
+                </a:solidFill>
+                <a:latin typeface="Inter"/>
+              </a:rPr>
+              <a:t>Closing visual placeholder</a:t>
+            </a:r>
+          </a:p>
+        </p:txBody>
+      </p:sp>
+      <p:sp>
+        <p:nvSpPr>
+          <p:cNvPr id="5" name="TextBox 4"/>
+          <p:cNvSpPr txBox="1"/>
+          <p:nvPr/>
+        </p:nvSpPr>
+        <p:spPr>
+          <a:xfrm>
+            <a:off x="822960" y="5715000"/>
+            <a:ext cx="4754880" cy="320040"/>
+          </a:xfrm>
+          <a:prstGeom prst="rect">
+            <a:avLst/>
+          </a:prstGeom>
+          <a:noFill/>
+        </p:spPr>
+        <p:txBody>
+          <a:bodyPr wrap="none" lIns="0" rIns="0" anchor="t">
+            <a:spAutoFit/>
+          </a:bodyPr>
+          <a:lstStyle/>
+          <a:p>
+            <a:r>
+              <a:rPr sz="1300" b="1">
+                <a:solidFill>
+                  <a:srgbClr val="0F766E"/>
+                </a:solidFill>
+                <a:latin typeface="Inter"/>
+              </a:rPr>
+              <a:t>contact@example.com  ·  company.com</a:t>
+            </a:r>
+          </a:p>
+        </p:txBody>
+      </p:sp>
+      <p:sp>
+        <p:nvSpPr>
+          <p:cNvPr id="6" name="Rectangle 5"/>
+          <p:cNvSpPr/>
+          <p:nvPr/>
+        </p:nvSpPr>
+        <p:spPr>
+          <a:xfrm>
+            <a:off x="594360" y="6446520"/>
+            <a:ext cx="10104120" cy="27432"/>
+          </a:xfrm>
+          <a:prstGeom prst="rect">
+            <a:avLst/>
+          </a:prstGeom>
+          <a:solidFill>
+            <a:srgbClr val="0F766E"/>
+          </a:solidFill>
+          <a:ln>
+            <a:noFill/>
+          </a:ln>
+        </p:spPr>
+        <p:style>
+          <a:lnRef idx="1">
+            <a:schemeClr val="accent1"/>
+          </a:lnRef>
+          <a:fillRef idx="3">
+            <a:schemeClr val="accent1"/>
+          </a:fillRef>
+          <a:effectRef idx="2">
+            <a:schemeClr val="accent1"/>
+          </a:effectRef>
+          <a:fontRef idx="minor">
+            <a:schemeClr val="lt1"/>
+          </a:fontRef>
+        </p:style>
+        <p:txBody>
+          <a:bodyPr rtlCol="0" anchor="ctr"/>
+          <a:lstStyle/>
+          <a:p>
+            <a:pPr algn="ctr"/>
+          </a:p>
+        </p:txBody>
+      </p:sp>
+      <p:sp>
+        <p:nvSpPr>
+          <p:cNvPr id="7" name="TextBox 6"/>
+          <p:cNvSpPr txBox="1"/>
+          <p:nvPr/>
+        </p:nvSpPr>
+        <p:spPr>
+          <a:xfrm>
+            <a:off x="594360" y="6510528"/>
+            <a:ext cx="4572000" cy="228600"/>
+          </a:xfrm>
+          <a:prstGeom prst="rect">
+            <a:avLst/>
+          </a:prstGeom>
+          <a:noFill/>
+        </p:spPr>
+        <p:txBody>
+          <a:bodyPr wrap="none" lIns="0" rIns="0" anchor="t">
+            <a:spAutoFit/>
+          </a:bodyPr>
+          <a:lstStyle/>
+          <a:p>
+            <a:r>
+              <a:rPr sz="800" b="0">
+                <a:solidFill>
+                  <a:srgbClr val="475569"/>
+                </a:solidFill>
+                <a:latin typeface="Inter"/>
+              </a:rPr>
+              <a:t>Closing / thanks slide</a:t>
             </a:r>
           </a:p>
         </p:txBody>

</xml_diff>